<commit_message>
Stack TV headline to match landing
Co-authored-by: Cursor <cursoragent@cursor.com>
</commit_message>
<xml_diff>
--- a/Hangbyme-TV-Screen.pptx
+++ b/Hangbyme-TV-Screen.pptx
@@ -4,15 +4,15 @@
   <p:embeddedFontLst>
     <p:embeddedFont>
       <p:font typeface="Syne" panose="020B0604020202020204" pitchFamily="34" charset="-122"/>
-      <p:regular r:id="rId8" fontKey="{F94F3719-5A21-40A7-BC1C-9952BEAF83FD}"/>
+      <p:regular r:id="rId8" fontKey="{8DE3D4D5-F962-4EEA-BDB4-73F1AD080F26}"/>
     </p:embeddedFont>
     <p:embeddedFont>
       <p:font typeface="IBM Plex Sans" panose="020B0604020202020204" pitchFamily="34" charset="-122"/>
-      <p:regular r:id="rId9" fontKey="{B855300A-3CF9-48A3-B90C-A084559E72D9}"/>
+      <p:regular r:id="rId9" fontKey="{CD76B968-A88A-4C98-AEFD-9BC0061B3736}"/>
     </p:embeddedFont>
     <p:embeddedFont>
       <p:font typeface="IBM Plex Sans Medium" panose="020B0604020202020204" pitchFamily="34" charset="-122"/>
-      <p:regular r:id="rId10" fontKey="{1DF48AC3-4CC7-408D-ACD9-7ACCC26AB0A5}"/>
+      <p:regular r:id="rId10" fontKey="{2B5DEF75-CB19-4869-8A44-E92EE5EDE334}"/>
     </p:embeddedFont>
   </p:embeddedFontLst>
   <p:sldMasterIdLst>
@@ -3126,7 +3126,7 @@
         </p:blipFill>
         <p:spPr>
           <a:xfrm>
-            <a:off x="548640" y="1783080"/>
+            <a:off x="548640" y="1481328"/>
             <a:ext cx="457200" cy="457200"/>
           </a:xfrm>
           <a:prstGeom prst="rect">
@@ -3142,7 +3142,7 @@
         </p:nvSpPr>
         <p:spPr>
           <a:xfrm>
-            <a:off x="1115568" y="1801368"/>
+            <a:off x="1115568" y="1499616"/>
             <a:ext cx="2377440" cy="502920"/>
           </a:xfrm>
           <a:prstGeom prst="rect">
@@ -3185,8 +3185,8 @@
         </p:nvSpPr>
         <p:spPr>
           <a:xfrm>
-            <a:off x="548640" y="2441448"/>
-            <a:ext cx="5227167" cy="2148840"/>
+            <a:off x="548640" y="2139696"/>
+            <a:ext cx="5227167" cy="2331720"/>
           </a:xfrm>
           <a:prstGeom prst="rect">
             <a:avLst/>
@@ -3201,7 +3201,7 @@
           <a:p>
             <a:pPr>
               <a:lnSpc>
-                <a:spcPct val="115000"/>
+                <a:spcPct val="102000"/>
               </a:lnSpc>
               <a:spcAft>
                 <a:spcPts val="0"/>
@@ -3223,7 +3223,8 @@
                 </a:solidFill>
                 <a:latin typeface="Syne"/>
               </a:rPr>
-              <a:t>first startup</a:t>
+              <a:t>first startup
+</a:t>
             </a:r>
             <a:r>
               <a:rPr sz="5000" b="1">
@@ -3232,7 +3233,8 @@
                 </a:solidFill>
                 <a:latin typeface="Syne"/>
               </a:rPr>
-              <a:t> social network for </a:t>
+              <a:t>social network
+for </a:t>
             </a:r>
             <a:r>
               <a:rPr sz="5000" b="1">
@@ -3254,7 +3256,7 @@
         </p:nvSpPr>
         <p:spPr>
           <a:xfrm>
-            <a:off x="548640" y="4315967"/>
+            <a:off x="548640" y="4407408"/>
             <a:ext cx="5227167" cy="1005840"/>
           </a:xfrm>
           <a:prstGeom prst="rect">

</xml_diff>